<commit_message>
Deck: acknowledgements on Slide 12 (Built with Llama, data source, AI-tool use); rebuilt Group10.pptx
Claude-Session: https://claude.ai/code/session_01MyKgYUYjWUJV7N1hpBJPwF
</commit_message>
<xml_diff>
--- a/slides/Group10.pptx
+++ b/slides/Group10.pptx
@@ -13872,6 +13872,75 @@
             </a:r>
             <a:endParaRPr lang="en-US" sz="1050" dirty="0"/>
           </a:p>
+          <a:p>
+            <a:pPr algn="l" indent="0" marL="0">
+              <a:lnSpc>
+                <a:spcPct val="100000"/>
+              </a:lnSpc>
+              <a:spcAft>
+                <a:spcPts val="300"/>
+              </a:spcAft>
+              <a:buNone/>
+            </a:pPr>
+            <a:r>
+              <a:rPr lang="en-US" sz="600" dirty="0">
+                <a:solidFill>
+                  <a:srgbClr val="17252C"/>
+                </a:solidFill>
+                <a:latin typeface="Calibri" pitchFamily="34" charset="0"/>
+                <a:ea typeface="Calibri" pitchFamily="34" charset="-122"/>
+                <a:cs typeface="Calibri" pitchFamily="34" charset="-120"/>
+              </a:rPr>
+              <a:t> </a:t>
+            </a:r>
+            <a:endParaRPr lang="en-US" sz="1050" dirty="0"/>
+          </a:p>
+          <a:p>
+            <a:pPr algn="l" indent="0" marL="0">
+              <a:lnSpc>
+                <a:spcPct val="100000"/>
+              </a:lnSpc>
+              <a:spcAft>
+                <a:spcPts val="300"/>
+              </a:spcAft>
+              <a:buNone/>
+            </a:pPr>
+            <a:r>
+              <a:rPr lang="en-US" sz="1050" b="1" dirty="0">
+                <a:solidFill>
+                  <a:srgbClr val="E39B2D"/>
+                </a:solidFill>
+                <a:latin typeface="Calibri" pitchFamily="34" charset="0"/>
+                <a:ea typeface="Calibri" pitchFamily="34" charset="-122"/>
+                <a:cs typeface="Calibri" pitchFamily="34" charset="-120"/>
+              </a:rPr>
+              <a:t>Evidence</a:t>
+            </a:r>
+            <a:endParaRPr lang="en-US" sz="1050" dirty="0"/>
+          </a:p>
+          <a:p>
+            <a:pPr algn="l" indent="0" marL="0">
+              <a:lnSpc>
+                <a:spcPct val="100000"/>
+              </a:lnSpc>
+              <a:spcAft>
+                <a:spcPts val="300"/>
+              </a:spcAft>
+              <a:buNone/>
+            </a:pPr>
+            <a:r>
+              <a:rPr lang="en-US" sz="1050" dirty="0">
+                <a:solidFill>
+                  <a:srgbClr val="FFFFFF"/>
+                </a:solidFill>
+                <a:latin typeface="Calibri" pitchFamily="34" charset="0"/>
+                <a:ea typeface="Calibri" pitchFamily="34" charset="-122"/>
+                <a:cs typeface="Calibri" pitchFamily="34" charset="-120"/>
+              </a:rPr>
+              <a:t>Every figure here is read from analysis/output/. All 55 JMeter runs reconcile sample-for-sample with the service log (0 failures); predictions are the version frozen under the golden-freeze tag before the first run.</a:t>
+            </a:r>
+            <a:endParaRPr lang="en-US" sz="1050" dirty="0"/>
+          </a:p>
         </p:txBody>
       </p:sp>
       <p:sp>
@@ -14758,6 +14827,92 @@
               <a:t>[30] The Matplotlib Development Team, "Matplotlib," version 3.11.2. [Online]. Available: &lt;https://matplotlib.org/&gt;. [Accessed: 8 October 2026].</a:t>
             </a:r>
             <a:endParaRPr lang="en-US" sz="800" dirty="0"/>
+          </a:p>
+        </p:txBody>
+      </p:sp>
+      <p:sp>
+        <p:nvSpPr>
+          <p:cNvPr id="6" name="Shape 4"/>
+          <p:cNvSpPr/>
+          <p:nvPr/>
+        </p:nvSpPr>
+        <p:spPr>
+          <a:xfrm>
+            <a:off x="502920" y="5440680"/>
+            <a:ext cx="11185855" cy="960120"/>
+          </a:xfrm>
+          <a:prstGeom prst="roundRect">
+            <a:avLst>
+              <a:gd name="adj" fmla="val 7619"/>
+            </a:avLst>
+          </a:prstGeom>
+          <a:solidFill>
+            <a:srgbClr val="EEF3F4"/>
+          </a:solidFill>
+          <a:ln w="12700">
+            <a:solidFill>
+              <a:srgbClr val="EEF3F4"/>
+            </a:solidFill>
+            <a:prstDash val="solid"/>
+          </a:ln>
+        </p:spPr>
+      </p:sp>
+      <p:sp>
+        <p:nvSpPr>
+          <p:cNvPr id="7" name="Text 5"/>
+          <p:cNvSpPr txBox="1"/>
+          <p:nvPr/>
+        </p:nvSpPr>
+        <p:spPr>
+          <a:xfrm>
+            <a:off x="594360" y="5468112"/>
+            <a:ext cx="11002975" cy="914400"/>
+          </a:xfrm>
+          <a:prstGeom prst="rect">
+            <a:avLst/>
+          </a:prstGeom>
+          <a:noFill/>
+          <a:ln/>
+        </p:spPr>
+        <p:txBody>
+          <a:bodyPr wrap="square" lIns="762" tIns="762" rIns="762" bIns="762" rtlCol="0" anchor="ctr"/>
+          <a:lstStyle/>
+          <a:p>
+            <a:pPr algn="l" indent="0" marL="0">
+              <a:lnSpc>
+                <a:spcPct val="100000"/>
+              </a:lnSpc>
+              <a:buNone/>
+            </a:pPr>
+            <a:r>
+              <a:rPr lang="en-US" sz="950" b="1" dirty="0">
+                <a:solidFill>
+                  <a:srgbClr val="1F6F78"/>
+                </a:solidFill>
+                <a:latin typeface="Calibri" pitchFamily="34" charset="0"/>
+                <a:ea typeface="Calibri" pitchFamily="34" charset="-122"/>
+                <a:cs typeface="Calibri" pitchFamily="34" charset="-120"/>
+              </a:rPr>
+              <a:t>Acknowledgements. </a:t>
+            </a:r>
+            <a:pPr algn="l" indent="0" marL="0">
+              <a:lnSpc>
+                <a:spcPct val="100000"/>
+              </a:lnSpc>
+              <a:buNone/>
+            </a:pPr>
+            <a:r>
+              <a:rPr lang="en-US" sz="950" dirty="0">
+                <a:solidFill>
+                  <a:srgbClr val="17252C"/>
+                </a:solidFill>
+                <a:latin typeface="Calibri" pitchFamily="34" charset="0"/>
+                <a:ea typeface="Calibri" pitchFamily="34" charset="-122"/>
+                <a:cs typeface="Calibri" pitchFamily="34" charset="-120"/>
+              </a:rPr>
+              <a:t>Built with Llama. Llama 3.2 is licensed under the Llama 3.2 Community License, Copyright © Meta Platforms, Inc. All Rights Reserved [16]. granite4:3b and qwen2.5:7b are Apache-2.0 [23]; Ollama is MIT [6]. Ticket narratives: the US CFPB Consumer Complaint Database [1], via the ICT3113 teaching team's extract [2], team rows 10000–10999. AI coding tools (Anthropic's Claude, via Claude Code) wrote most of the code and drafted documents; the golden-set labels are the two labellers' own, and every number comes from our logs — statement in docs/references.md §9.1.</a:t>
+            </a:r>
+            <a:endParaRPr lang="en-US" sz="950" dirty="0"/>
           </a:p>
         </p:txBody>
       </p:sp>
@@ -26158,7 +26313,7 @@
                           <a:ea typeface="Calibri" pitchFamily="34" charset="-122"/>
                           <a:cs typeface="Calibri" pitchFamily="34" charset="-120"/>
                         </a:rPr>
-                        <a:t>29.7.2</a:t>
+                        <a:t>Engine 29.7.2, native</a:t>
                       </a:r>
                       <a:endParaRPr lang="en-US" sz="1000" dirty="0">
                         <a:latin typeface="Calibri" charset="0"/>
@@ -26242,7 +26397,7 @@
                           <a:ea typeface="Calibri" pitchFamily="34" charset="-122"/>
                           <a:cs typeface="Calibri" pitchFamily="34" charset="-120"/>
                         </a:rPr>
-                        <a:t>version:0.34.3</a:t>
+                        <a:t>0.34.3 (container)</a:t>
                       </a:r>
                       <a:endParaRPr lang="en-US" sz="1000" dirty="0">
                         <a:latin typeface="Calibri" charset="0"/>
@@ -26845,7 +27000,7 @@
                           <a:ea typeface="Calibri" pitchFamily="34" charset="-122"/>
                           <a:cs typeface="Calibri" pitchFamily="34" charset="-120"/>
                         </a:rPr>
-                        <a:t>daemon not reachable from this shell</a:t>
+                        <a:t>not used (Docker Desktop quit for the campaign)</a:t>
                       </a:r>
                       <a:endParaRPr lang="en-US" sz="1000" dirty="0">
                         <a:latin typeface="Calibri" charset="0"/>
@@ -28594,7 +28749,7 @@
                 <a:ea typeface="Calibri" pitchFamily="34" charset="-122"/>
                 <a:cs typeface="Calibri" pitchFamily="34" charset="-120"/>
               </a:rPr>
-              <a:t>stress_ramp: 1, 5, 9, 13, 17, 21 tickets/min, 120 s per step + 150 s drain; once per model; limit = first step with p95 &gt; 10 s or &gt; 5% errors</a:t>
+              <a:t>stress_ramp: 1, 5, 9, 13, 17, 21 tickets/min, 120 s steps + 150 s drain, once per model; then 10–60/min for any model with no limit (decided in advance). Limit = first step with p95 &gt; 10 s or &gt; 5% errors</a:t>
             </a:r>
             <a:endParaRPr lang="en-US" sz="1050" dirty="0"/>
           </a:p>

</xml_diff>